<commit_message>
docs(specs): remediate compliance and normalize accountability across portfolio
- Add specs 005-012 (reporting, parent-portal, adaptive, teacher-assessment, SIS, CMS, hierarchy, A/B testing) with spec/plan/tasks

- Remediate 005/008/010 to GO: EU AI Act Art.9/10/12/13/14/15 + Annex IV fragments, suppression policy, human-oversight gates

- Normalize accountability labels to '(Accountable: agents/*.chatmode.md)' across all tasks.md

- Add 'avoid overwrites' implementation notes (EXTEND/REUSE + _shared/sync.ps1 mirror rule) to tasks.md 005-012

- Sync demo app updates (auth, db, login pages, director-portal reporting/Power BI embed) and restitution assets
</commit_message>
<xml_diff>
--- a/Restitution01/build/LearnEU-CXO-Restitution_V1.pptx
+++ b/Restitution01/build/LearnEU-CXO-Restitution_V1.pptx
@@ -47,6 +47,7 @@
     <p:sldId id="291" r:id="rId38"/>
     <p:sldId id="292" r:id="rId39"/>
     <p:sldId id="293" r:id="rId40"/>
+    <p:sldId id="295" r:id="rId46"/>
   </p:sldIdLst>
   <p:sldSz cx="9144000" cy="5143500" type="screen16x9"/>
   <p:notesSz cx="5143500" cy="9144000"/>
@@ -3052,6 +3053,31 @@
         <p14:creationId xmlns:p14="http://schemas.microsoft.com/office/powerpoint/2010/main" val="1024086991"/>
       </p:ext>
     </p:extLst>
+  </p:cSld>
+  <p:clrMapOvr>
+    <a:masterClrMapping/>
+  </p:clrMapOvr>
+</p:notes>
+</file>
+
+<file path=ppt/notesSlides/notesSlide39.xml><?xml version="1.0" encoding="utf-8"?>
+<p:notes xmlns:a="http://schemas.openxmlformats.org/drawingml/2006/main" xmlns:p="http://schemas.openxmlformats.org/presentationml/2006/main" xmlns:r="http://schemas.openxmlformats.org/officeDocument/2006/relationships">
+  <p:cSld>
+    <p:spTree>
+      <p:nvGrpSpPr>
+        <p:cNvPr id="1" name=""/>
+        <p:cNvGrpSpPr/>
+        <p:nvPr/>
+      </p:nvGrpSpPr>
+      <p:grpSpPr>
+        <a:xfrm>
+          <a:off x="0" y="0"/>
+          <a:ext cx="0" cy="0"/>
+          <a:chOff x="0" y="0"/>
+          <a:chExt cx="0" cy="0"/>
+        </a:xfrm>
+      </p:grpSpPr>
+    </p:spTree>
   </p:cSld>
   <p:clrMapOvr>
     <a:masterClrMapping/>
@@ -23360,6 +23386,530 @@
             <a:extLst>
               <a:ext uri="{96DAC541-7B7A-43D3-8B79-37D633B846F1}">
                 <asvg:svgBlip xmlns:asvg="http://schemas.microsoft.com/office/drawing/2016/SVG/main" r:embed="rId5"/>
+              </a:ext>
+            </a:extLst>
+          </a:blip>
+          <a:stretch>
+            <a:fillRect/>
+          </a:stretch>
+        </p:blipFill>
+        <p:spPr>
+          <a:xfrm>
+            <a:off x="52026" y="4753305"/>
+            <a:ext cx="859220" cy="429610"/>
+          </a:xfrm>
+          <a:prstGeom prst="rect">
+            <a:avLst/>
+          </a:prstGeom>
+        </p:spPr>
+      </p:pic>
+    </p:spTree>
+  </p:cSld>
+  <p:clrMapOvr>
+    <a:masterClrMapping/>
+  </p:clrMapOvr>
+</p:sld>
+</file>
+
+<file path=ppt/slides/slide40.xml><?xml version="1.0" encoding="utf-8"?>
+<p:sld xmlns:a="http://schemas.openxmlformats.org/drawingml/2006/main" xmlns:p="http://schemas.openxmlformats.org/presentationml/2006/main" xmlns:r="http://schemas.openxmlformats.org/officeDocument/2006/relationships">
+  <p:cSld>
+    <p:spTree>
+      <p:nvGrpSpPr>
+        <p:cNvPr id="1" name=""/>
+        <p:cNvGrpSpPr/>
+        <p:nvPr/>
+      </p:nvGrpSpPr>
+      <p:grpSpPr/>
+      <p:sp>
+        <p:nvSpPr>
+          <p:cNvPr id="2" name="Shape 0"/>
+          <p:cNvSpPr/>
+          <p:nvPr/>
+        </p:nvSpPr>
+        <p:spPr>
+          <a:xfrm>
+            <a:off x="548640" y="274320"/>
+            <a:ext cx="2011680" cy="292608"/>
+          </a:xfrm>
+          <a:prstGeom prst="roundRect">
+            <a:avLst>
+              <a:gd name="adj" fmla="val 31250"/>
+            </a:avLst>
+          </a:prstGeom>
+          <a:solidFill>
+            <a:srgbClr val="888888">
+              <a:alpha val="12000"/>
+            </a:srgbClr>
+          </a:solidFill>
+          <a:ln/>
+        </p:spPr>
+        <p:txBody>
+          <a:bodyPr/>
+          <a:lstStyle/>
+          <a:p>
+            <a:endParaRPr lang="en-US"/>
+          </a:p>
+        </p:txBody>
+      </p:sp>
+      <p:sp>
+        <p:nvSpPr>
+          <p:cNvPr id="3" name="Text 1"/>
+          <p:cNvSpPr/>
+          <p:nvPr/>
+        </p:nvSpPr>
+        <p:spPr>
+          <a:xfrm>
+            <a:off x="685800" y="274320"/>
+            <a:ext cx="1828800" cy="292608"/>
+          </a:xfrm>
+          <a:prstGeom prst="rect">
+            <a:avLst/>
+          </a:prstGeom>
+          <a:noFill/>
+          <a:ln/>
+        </p:spPr>
+        <p:txBody>
+          <a:bodyPr wrap="square" lIns="0" tIns="0" rIns="0" bIns="0" rtlCol="0" anchor="ctr"/>
+          <a:lstStyle/>
+          <a:p>
+            <a:pPr marL="0" indent="0">
+              <a:buNone/>
+            </a:pPr>
+            <a:r>
+              <a:rPr lang="en-US" sz="800" b="1" kern="0" spc="300" dirty="0">
+                <a:solidFill>
+                  <a:srgbClr val="888888"/>
+                </a:solidFill>
+                <a:latin typeface="Calibri" pitchFamily="34" charset="0"/>
+                <a:ea typeface="Calibri" pitchFamily="34" charset="-122"/>
+                <a:cs typeface="Calibri" pitchFamily="34" charset="-120"/>
+              </a:rPr>
+              <a:t>APPENDIX</a:t>
+            </a:r>
+            <a:endParaRPr lang="en-US" sz="800" dirty="0"/>
+          </a:p>
+        </p:txBody>
+      </p:sp>
+      <p:pic>
+        <p:nvPicPr>
+          <p:cNvPr id="4" name="Image 0" descr="preencoded.png"/>
+          <p:cNvPicPr>
+            <a:picLocks noChangeAspect="1"/>
+          </p:cNvPicPr>
+          <p:nvPr/>
+        </p:nvPicPr>
+        <p:blipFill>
+          <a:blip r:embed="rId2"/>
+          <a:stretch>
+            <a:fillRect/>
+          </a:stretch>
+        </p:blipFill>
+        <p:spPr>
+          <a:xfrm>
+            <a:off x="8229600" y="274320"/>
+            <a:ext cx="502920" cy="502920"/>
+          </a:xfrm>
+          <a:prstGeom prst="rect">
+            <a:avLst/>
+          </a:prstGeom>
+        </p:spPr>
+      </p:pic>
+      <p:sp>
+        <p:nvSpPr>
+          <p:cNvPr id="5" name="Text 2"/>
+          <p:cNvSpPr/>
+          <p:nvPr/>
+        </p:nvSpPr>
+        <p:spPr>
+          <a:xfrm>
+            <a:off x="548640" y="548640"/>
+            <a:ext cx="7498080" cy="502920"/>
+          </a:xfrm>
+          <a:prstGeom prst="rect">
+            <a:avLst/>
+          </a:prstGeom>
+          <a:noFill/>
+          <a:ln/>
+        </p:spPr>
+        <p:txBody>
+          <a:bodyPr wrap="square" lIns="0" tIns="0" rIns="0" bIns="0" rtlCol="0" anchor="ctr"/>
+          <a:lstStyle/>
+          <a:p>
+            <a:pPr marL="0" indent="0">
+              <a:buNone/>
+            </a:pPr>
+            <a:r>
+              <a:rPr lang="en-US" sz="2200" b="1" dirty="0">
+                <a:solidFill>
+                  <a:srgbClr val="2D2D2D"/>
+                </a:solidFill>
+                <a:latin typeface="Georgia" pitchFamily="34" charset="0"/>
+                <a:ea typeface="Georgia" pitchFamily="34" charset="-122"/>
+                <a:cs typeface="Georgia" pitchFamily="34" charset="-120"/>
+              </a:rPr>
+              <a:t>A18 · Scale plan to 4.1M learners</a:t>
+            </a:r>
+            <a:endParaRPr lang="en-US" sz="2200" dirty="0"/>
+          </a:p>
+        </p:txBody>
+      </p:sp>
+      <p:sp>
+        <p:nvSpPr>
+          <p:cNvPr id="6" name="Text 3"/>
+          <p:cNvSpPr/>
+          <p:nvPr/>
+        </p:nvSpPr>
+        <p:spPr>
+          <a:xfrm>
+            <a:off x="548640" y="1051560"/>
+            <a:ext cx="8046720" cy="274320"/>
+          </a:xfrm>
+          <a:prstGeom prst="rect">
+            <a:avLst/>
+          </a:prstGeom>
+          <a:noFill/>
+          <a:ln/>
+        </p:spPr>
+        <p:txBody>
+          <a:bodyPr wrap="square" lIns="0" tIns="0" rIns="0" bIns="0" rtlCol="0" anchor="ctr"/>
+          <a:lstStyle/>
+          <a:p>
+            <a:pPr marL="0" indent="0">
+              <a:buNone/>
+            </a:pPr>
+            <a:r>
+              <a:rPr lang="en-US" sz="1100" dirty="0">
+                <a:solidFill>
+                  <a:srgbClr val="888888"/>
+                </a:solidFill>
+                <a:latin typeface="Calibri" pitchFamily="34" charset="0"/>
+                <a:ea typeface="Calibri" pitchFamily="34" charset="-122"/>
+                <a:cs typeface="Calibri" pitchFamily="34" charset="-120"/>
+              </a:rPr>
+              <a:t>Capacity, resilience, and cost discipline in one operating model</a:t>
+            </a:r>
+            <a:endParaRPr lang="en-US" sz="1100" dirty="0"/>
+          </a:p>
+        </p:txBody>
+      </p:sp>
+      <p:sp>
+        <p:nvSpPr>
+          <p:cNvPr id="7" name="Text 4"/>
+          <p:cNvSpPr/>
+          <p:nvPr/>
+        </p:nvSpPr>
+        <p:spPr>
+          <a:xfrm>
+            <a:off x="548640" y="1463040"/>
+            <a:ext cx="3749040" cy="3383280"/>
+          </a:xfrm>
+          <a:prstGeom prst="rect">
+            <a:avLst/>
+          </a:prstGeom>
+          <a:noFill/>
+          <a:ln/>
+        </p:spPr>
+        <p:txBody>
+          <a:bodyPr wrap="square" lIns="0" tIns="0" rIns="0" bIns="0" rtlCol="0" anchor="t"/>
+          <a:lstStyle/>
+          <a:p>
+            <a:pPr marL="342900" indent="-342900">
+              <a:spcAft>
+                <a:spcPts val="600"/>
+              </a:spcAft>
+              <a:buSzPct val="100000"/>
+              <a:buChar char="●"/>
+            </a:pPr>
+            <a:r>
+              <a:rPr b="1" sz="1200">
+                <a:solidFill>
+                  <a:srgbClr val="4DA8DA"/>
+                </a:solidFill>
+                <a:latin typeface="Calibri"/>
+              </a:rPr>
+              <a:t>Peak design point  </a:t>
+            </a:r>
+            <a:r>
+              <a:rPr b="0" sz="1200">
+                <a:solidFill>
+                  <a:srgbClr val="555555"/>
+                </a:solidFill>
+                <a:latin typeface="Calibri"/>
+              </a:rPr>
+              <a:t>120k–220k concurrent sessions (exam windows)</a:t>
+            </a:r>
+            <a:endParaRPr lang="en-US" sz="1200" dirty="0"/>
+          </a:p>
+          <a:p>
+            <a:pPr marL="342900" indent="-342900">
+              <a:spcAft>
+                <a:spcPts val="600"/>
+              </a:spcAft>
+              <a:buSzPct val="100000"/>
+              <a:buChar char="●"/>
+            </a:pPr>
+            <a:r>
+              <a:rPr b="1" sz="1200">
+                <a:solidFill>
+                  <a:srgbClr val="4DA8DA"/>
+                </a:solidFill>
+                <a:latin typeface="Calibri"/>
+              </a:rPr>
+              <a:t>API SLO target  </a:t>
+            </a:r>
+            <a:r>
+              <a:rPr b="0" sz="1200">
+                <a:solidFill>
+                  <a:srgbClr val="555555"/>
+                </a:solidFill>
+                <a:latin typeface="Calibri"/>
+              </a:rPr>
+              <a:t>p95 &lt; 300 ms reads; &lt; 500 ms writes</a:t>
+            </a:r>
+            <a:endParaRPr lang="en-US" sz="1200" dirty="0"/>
+          </a:p>
+          <a:p>
+            <a:pPr marL="342900" indent="-342900">
+              <a:spcAft>
+                <a:spcPts val="600"/>
+              </a:spcAft>
+              <a:buSzPct val="100000"/>
+              <a:buChar char="●"/>
+            </a:pPr>
+            <a:r>
+              <a:rPr b="1" sz="1200">
+                <a:solidFill>
+                  <a:srgbClr val="4DA8DA"/>
+                </a:solidFill>
+                <a:latin typeface="Calibri"/>
+              </a:rPr>
+              <a:t>PostgreSQL tuning  </a:t>
+            </a:r>
+            <a:r>
+              <a:rPr b="0" sz="1200">
+                <a:solidFill>
+                  <a:srgbClr val="555555"/>
+                </a:solidFill>
+                <a:latin typeface="Calibri"/>
+              </a:rPr>
+              <a:t>logical partitioning + read replicas + async buffering</a:t>
+            </a:r>
+            <a:endParaRPr lang="en-US" sz="1200" dirty="0"/>
+          </a:p>
+          <a:p>
+            <a:pPr marL="342900" indent="-342900">
+              <a:spcAft>
+                <a:spcPts val="600"/>
+              </a:spcAft>
+              <a:buSzPct val="100000"/>
+              <a:buChar char="●"/>
+            </a:pPr>
+            <a:r>
+              <a:rPr b="1" sz="1200">
+                <a:solidFill>
+                  <a:srgbClr val="4DA8DA"/>
+                </a:solidFill>
+                <a:latin typeface="Calibri"/>
+              </a:rPr>
+              <a:t>Redis target  </a:t>
+            </a:r>
+            <a:r>
+              <a:rPr b="0" sz="1200">
+                <a:solidFill>
+                  <a:srgbClr val="555555"/>
+                </a:solidFill>
+                <a:latin typeface="Calibri"/>
+              </a:rPr>
+              <a:t>&gt;80% hit ratio on hot learner &amp; content paths</a:t>
+            </a:r>
+            <a:endParaRPr lang="en-US" sz="1200" dirty="0"/>
+          </a:p>
+        </p:txBody>
+      </p:sp>
+      <p:sp>
+        <p:nvSpPr>
+          <p:cNvPr id="8" name="Text 5"/>
+          <p:cNvSpPr/>
+          <p:nvPr/>
+        </p:nvSpPr>
+        <p:spPr>
+          <a:xfrm>
+            <a:off x="4846320" y="1463040"/>
+            <a:ext cx="3749040" cy="3383280"/>
+          </a:xfrm>
+          <a:prstGeom prst="rect">
+            <a:avLst/>
+          </a:prstGeom>
+          <a:noFill/>
+          <a:ln/>
+        </p:spPr>
+        <p:txBody>
+          <a:bodyPr wrap="square" lIns="0" tIns="0" rIns="0" bIns="0" rtlCol="0" anchor="t"/>
+          <a:lstStyle/>
+          <a:p>
+            <a:pPr marL="342900" indent="-342900">
+              <a:spcAft>
+                <a:spcPts val="600"/>
+              </a:spcAft>
+              <a:buSzPct val="100000"/>
+              <a:buChar char="●"/>
+            </a:pPr>
+            <a:r>
+              <a:rPr b="1" sz="1200">
+                <a:solidFill>
+                  <a:srgbClr val="4DA8DA"/>
+                </a:solidFill>
+                <a:latin typeface="Calibri"/>
+              </a:rPr>
+              <a:t>Availability target  </a:t>
+            </a:r>
+            <a:r>
+              <a:rPr b="0" sz="1200">
+                <a:solidFill>
+                  <a:srgbClr val="555555"/>
+                </a:solidFill>
+                <a:latin typeface="Calibri"/>
+              </a:rPr>
+              <a:t>99.95% baseline, 99.99% for critical journeys</a:t>
+            </a:r>
+            <a:endParaRPr lang="en-US" sz="1200" dirty="0"/>
+          </a:p>
+          <a:p>
+            <a:pPr marL="342900" indent="-342900">
+              <a:spcAft>
+                <a:spcPts val="600"/>
+              </a:spcAft>
+              <a:buSzPct val="100000"/>
+              <a:buChar char="●"/>
+            </a:pPr>
+            <a:r>
+              <a:rPr b="1" sz="1200">
+                <a:solidFill>
+                  <a:srgbClr val="4DA8DA"/>
+                </a:solidFill>
+                <a:latin typeface="Calibri"/>
+              </a:rPr>
+              <a:t>EU data residency  </a:t>
+            </a:r>
+            <a:r>
+              <a:rPr b="0" sz="1200">
+                <a:solidFill>
+                  <a:srgbClr val="555555"/>
+                </a:solidFill>
+                <a:latin typeface="Calibri"/>
+              </a:rPr>
+              <a:t>EU-only with quarterly multi-region DR drills</a:t>
+            </a:r>
+            <a:endParaRPr lang="en-US" sz="1200" dirty="0"/>
+          </a:p>
+          <a:p>
+            <a:pPr marL="342900" indent="-342900">
+              <a:spcAft>
+                <a:spcPts val="600"/>
+              </a:spcAft>
+              <a:buSzPct val="100000"/>
+              <a:buChar char="●"/>
+            </a:pPr>
+            <a:r>
+              <a:rPr b="1" sz="1200">
+                <a:solidFill>
+                  <a:srgbClr val="4DA8DA"/>
+                </a:solidFill>
+                <a:latin typeface="Calibri"/>
+              </a:rPr>
+              <a:t>FinOps north star  </a:t>
+            </a:r>
+            <a:r>
+              <a:rPr b="0" sz="1200">
+                <a:solidFill>
+                  <a:srgbClr val="555555"/>
+                </a:solidFill>
+                <a:latin typeface="Calibri"/>
+              </a:rPr>
+              <a:t>cost per active learner per month, tracked bi-weekly</a:t>
+            </a:r>
+            <a:endParaRPr lang="en-US" sz="1200" dirty="0"/>
+          </a:p>
+          <a:p>
+            <a:pPr marL="342900" indent="-342900">
+              <a:spcAft>
+                <a:spcPts val="600"/>
+              </a:spcAft>
+              <a:buSzPct val="100000"/>
+              <a:buChar char="●"/>
+            </a:pPr>
+            <a:r>
+              <a:rPr b="1" sz="1200">
+                <a:solidFill>
+                  <a:srgbClr val="4DA8DA"/>
+                </a:solidFill>
+                <a:latin typeface="Calibri"/>
+              </a:rPr>
+              <a:t>Capacity reserve  </a:t>
+            </a:r>
+            <a:r>
+              <a:rPr b="0" sz="1200">
+                <a:solidFill>
+                  <a:srgbClr val="555555"/>
+                </a:solidFill>
+                <a:latin typeface="Calibri"/>
+              </a:rPr>
+              <a:t>+30% normal headroom, +100% exam headroom</a:t>
+            </a:r>
+            <a:endParaRPr lang="en-US" sz="1200" dirty="0"/>
+          </a:p>
+        </p:txBody>
+      </p:sp>
+      <p:pic>
+        <p:nvPicPr>
+          <p:cNvPr id="12" name="Picture 11" descr="File:Microsoft logo (2012).svg - Wikimedia Commons">
+            <a:extLst>
+              <a:ext uri="{FF2B5EF4-FFF2-40B4-BE49-F238E27FC236}">
+                <a16:creationId xmlns:a16="http://schemas.microsoft.com/office/drawing/2014/main" id="{631A1046-7019-5124-C567-FDE6C3F3FB92}"/>
+              </a:ext>
+            </a:extLst>
+          </p:cNvPr>
+          <p:cNvPicPr>
+            <a:picLocks noChangeAspect="1"/>
+          </p:cNvPicPr>
+          <p:nvPr/>
+        </p:nvPicPr>
+        <p:blipFill>
+          <a:blip r:embed="rId3"/>
+          <a:stretch>
+            <a:fillRect/>
+          </a:stretch>
+        </p:blipFill>
+        <p:spPr>
+          <a:xfrm>
+            <a:off x="8048296" y="4854444"/>
+            <a:ext cx="1001111" cy="213518"/>
+          </a:xfrm>
+          <a:prstGeom prst="rect">
+            <a:avLst/>
+          </a:prstGeom>
+        </p:spPr>
+      </p:pic>
+      <p:pic>
+        <p:nvPicPr>
+          <p:cNvPr id="14" name="Graphic 13" descr="Leading Tech Education">
+            <a:extLst>
+              <a:ext uri="{FF2B5EF4-FFF2-40B4-BE49-F238E27FC236}">
+                <a16:creationId xmlns:a16="http://schemas.microsoft.com/office/drawing/2014/main" id="{AC33CD75-5027-C2EC-7629-CCDC1176EAB2}"/>
+              </a:ext>
+            </a:extLst>
+          </p:cNvPr>
+          <p:cNvPicPr>
+            <a:picLocks noChangeAspect="1"/>
+          </p:cNvPicPr>
+          <p:nvPr/>
+        </p:nvPicPr>
+        <p:blipFill>
+          <a:blip>
+            <a:extLst>
+              <a:ext uri="{96DAC541-7B7A-43D3-8B79-37D633B846F1}">
+                <asvg:svgBlip xmlns:asvg="http://schemas.microsoft.com/office/drawing/2016/SVG/main" r:embed="rId4"/>
               </a:ext>
             </a:extLst>
           </a:blip>

</xml_diff>